<commit_message>
docs: refresh judge assets from the 4857d79 live deployment
- Re-shoot docs/screenshots 09-14 on agri-guard-api-live.vercel.app:
  field-scale GNSS farm with the boundary evidence card, labeled
  [SIMULATED] timelines and explicit PENDING settlement.
- Re-record the 121 s demo video on the live URL (real Run Scenario
  claim), keeping the original narration and subtitles.
- Swap the deck's screenshots (slides 1, 5, 7, 9) and fix slide 1 date
  and slide 10 SAM / ARR wording to match IMPACT_AND_MARKET.md.
- Update the submission checklist verification record (15/15 probe,
  56/56 tests, new asset hashes).

Co-Authored-By: Claude Opus 5.5 <noreply@anthropic.com>
Claude-Session: https://claude.ai/code/session_016nzEh2KMZpkJCi9Y43w9jZ
</commit_message>
<xml_diff>
--- a/docs/AgriGuard_Presentation_submission.pptx
+++ b/docs/AgriGuard_Presentation_submission.pptx
@@ -1866,6 +1866,10 @@
             <a:noFill/>
           </a:ln>
         </p:spPr>
+        <p:txBody xmlns:a="http://schemas.openxmlformats.org/drawingml/2006/main">
+          <a:bodyPr/>
+          <a:p/>
+        </p:txBody>
       </p:sp>
       <p:sp>
         <p:nvSpPr>
@@ -2010,6 +2014,10 @@
             <a:noFill/>
           </a:ln>
         </p:spPr>
+        <p:txBody xmlns:a="http://schemas.openxmlformats.org/drawingml/2006/main">
+          <a:bodyPr/>
+          <a:p/>
+        </p:txBody>
       </p:sp>
       <p:sp>
         <p:nvSpPr>
@@ -2189,7 +2197,7 @@
                 <a:ea typeface="Arial"/>
                 <a:cs typeface="Arial"/>
               </a:rPr>
-              <a:t>Public demo  |  September 2026</a:t>
+              <a:t>Public demo  |  November 2026</a:t>
             </a:r>
           </a:p>
         </p:txBody>
@@ -2248,6 +2256,10 @@
             <a:noFill/>
           </a:ln>
         </p:spPr>
+        <p:txBody xmlns:a="http://schemas.openxmlformats.org/drawingml/2006/main">
+          <a:bodyPr/>
+          <a:p/>
+        </p:txBody>
       </p:sp>
       <p:sp>
         <p:nvSpPr>
@@ -2535,6 +2547,10 @@
             <a:noFill/>
           </a:ln>
         </p:spPr>
+        <p:txBody xmlns:a="http://schemas.openxmlformats.org/drawingml/2006/main">
+          <a:bodyPr/>
+          <a:p/>
+        </p:txBody>
       </p:sp>
       <p:sp>
         <p:nvSpPr>
@@ -2565,6 +2581,10 @@
             <a:noFill/>
           </a:ln>
         </p:spPr>
+        <p:txBody xmlns:a="http://schemas.openxmlformats.org/drawingml/2006/main">
+          <a:bodyPr/>
+          <a:p/>
+        </p:txBody>
       </p:sp>
       <p:sp>
         <p:nvSpPr>
@@ -3310,7 +3330,7 @@
                 <a:ea typeface="Arial"/>
                 <a:cs typeface="Arial"/>
               </a:rPr>
-              <a:t>120M farms across Sub-Saharan Africa and Southeast Asia.</a:t>
+              <a:t>120M farms across Sub-Saharan Africa (Africa-first; Southeast Asia is upside).</a:t>
             </a:r>
           </a:p>
         </p:txBody>
@@ -3424,7 +3444,7 @@
                 <a:ea typeface="Arial"/>
                 <a:cs typeface="Arial"/>
               </a:rPr>
-              <a:t>120,000 insured farmers by Year 3 and about $3M ARR target.</a:t>
+              <a:t>120,000 insured farmers by Year 3: ~$3M GWP, ~$0.9-1.2M platform ARR.</a:t>
             </a:r>
           </a:p>
         </p:txBody>
@@ -3601,6 +3621,10 @@
             <a:noFill/>
           </a:ln>
         </p:spPr>
+        <p:txBody xmlns:a="http://schemas.openxmlformats.org/drawingml/2006/main">
+          <a:bodyPr/>
+          <a:p/>
+        </p:txBody>
       </p:sp>
       <p:sp>
         <p:nvSpPr>
@@ -3631,6 +3655,10 @@
             <a:noFill/>
           </a:ln>
         </p:spPr>
+        <p:txBody xmlns:a="http://schemas.openxmlformats.org/drawingml/2006/main">
+          <a:bodyPr/>
+          <a:p/>
+        </p:txBody>
       </p:sp>
       <p:sp>
         <p:nvSpPr>
@@ -3775,6 +3803,10 @@
             <a:noFill/>
           </a:ln>
         </p:spPr>
+        <p:txBody xmlns:a="http://schemas.openxmlformats.org/drawingml/2006/main">
+          <a:bodyPr/>
+          <a:p/>
+        </p:txBody>
       </p:sp>
       <p:sp>
         <p:nvSpPr>
@@ -3976,6 +4008,10 @@
             <a:noFill/>
           </a:ln>
         </p:spPr>
+        <p:txBody xmlns:a="http://schemas.openxmlformats.org/drawingml/2006/main">
+          <a:bodyPr/>
+          <a:p/>
+        </p:txBody>
       </p:sp>
       <p:sp>
         <p:nvSpPr>
@@ -4177,6 +4213,10 @@
             <a:noFill/>
           </a:ln>
         </p:spPr>
+        <p:txBody xmlns:a="http://schemas.openxmlformats.org/drawingml/2006/main">
+          <a:bodyPr/>
+          <a:p/>
+        </p:txBody>
       </p:sp>
       <p:sp>
         <p:nvSpPr>
@@ -4521,6 +4561,10 @@
             <a:noFill/>
           </a:ln>
         </p:spPr>
+        <p:txBody xmlns:a="http://schemas.openxmlformats.org/drawingml/2006/main">
+          <a:bodyPr/>
+          <a:p/>
+        </p:txBody>
       </p:sp>
       <p:sp>
         <p:nvSpPr>
@@ -4791,6 +4835,10 @@
             <a:noFill/>
           </a:ln>
         </p:spPr>
+        <p:txBody xmlns:a="http://schemas.openxmlformats.org/drawingml/2006/main">
+          <a:bodyPr/>
+          <a:p/>
+        </p:txBody>
       </p:sp>
       <p:sp>
         <p:nvSpPr>
@@ -5295,6 +5343,10 @@
             <a:noFill/>
           </a:ln>
         </p:spPr>
+        <p:txBody xmlns:a="http://schemas.openxmlformats.org/drawingml/2006/main">
+          <a:bodyPr/>
+          <a:p/>
+        </p:txBody>
       </p:sp>
       <p:sp>
         <p:nvSpPr>
@@ -5325,6 +5377,10 @@
             <a:noFill/>
           </a:ln>
         </p:spPr>
+        <p:txBody xmlns:a="http://schemas.openxmlformats.org/drawingml/2006/main">
+          <a:bodyPr/>
+          <a:p/>
+        </p:txBody>
       </p:sp>
       <p:sp>
         <p:nvSpPr>
@@ -5469,6 +5525,10 @@
             <a:noFill/>
           </a:ln>
         </p:spPr>
+        <p:txBody xmlns:a="http://schemas.openxmlformats.org/drawingml/2006/main">
+          <a:bodyPr/>
+          <a:p/>
+        </p:txBody>
       </p:sp>
       <p:sp>
         <p:nvSpPr>
@@ -5613,6 +5673,10 @@
             <a:noFill/>
           </a:ln>
         </p:spPr>
+        <p:txBody xmlns:a="http://schemas.openxmlformats.org/drawingml/2006/main">
+          <a:bodyPr/>
+          <a:p/>
+        </p:txBody>
       </p:sp>
       <p:sp>
         <p:nvSpPr>
@@ -5757,6 +5821,10 @@
             <a:noFill/>
           </a:ln>
         </p:spPr>
+        <p:txBody xmlns:a="http://schemas.openxmlformats.org/drawingml/2006/main">
+          <a:bodyPr/>
+          <a:p/>
+        </p:txBody>
       </p:sp>
       <p:sp>
         <p:nvSpPr>
@@ -5901,6 +5969,10 @@
             <a:noFill/>
           </a:ln>
         </p:spPr>
+        <p:txBody xmlns:a="http://schemas.openxmlformats.org/drawingml/2006/main">
+          <a:bodyPr/>
+          <a:p/>
+        </p:txBody>
       </p:sp>
       <p:sp>
         <p:nvSpPr>
@@ -6359,6 +6431,10 @@
             <a:noFill/>
           </a:ln>
         </p:spPr>
+        <p:txBody xmlns:a="http://schemas.openxmlformats.org/drawingml/2006/main">
+          <a:bodyPr/>
+          <a:p/>
+        </p:txBody>
       </p:sp>
       <p:sp>
         <p:nvSpPr>
@@ -6389,6 +6465,10 @@
             <a:noFill/>
           </a:ln>
         </p:spPr>
+        <p:txBody xmlns:a="http://schemas.openxmlformats.org/drawingml/2006/main">
+          <a:bodyPr/>
+          <a:p/>
+        </p:txBody>
       </p:sp>
       <p:sp>
         <p:nvSpPr>
@@ -6704,6 +6784,10 @@
             <a:noFill/>
           </a:ln>
         </p:spPr>
+        <p:txBody xmlns:a="http://schemas.openxmlformats.org/drawingml/2006/main">
+          <a:bodyPr/>
+          <a:p/>
+        </p:txBody>
       </p:sp>
       <p:sp>
         <p:nvSpPr>
@@ -6905,6 +6989,10 @@
             <a:noFill/>
           </a:ln>
         </p:spPr>
+        <p:txBody xmlns:a="http://schemas.openxmlformats.org/drawingml/2006/main">
+          <a:bodyPr/>
+          <a:p/>
+        </p:txBody>
       </p:sp>
       <p:sp>
         <p:nvSpPr>
@@ -7106,6 +7194,10 @@
             <a:noFill/>
           </a:ln>
         </p:spPr>
+        <p:txBody xmlns:a="http://schemas.openxmlformats.org/drawingml/2006/main">
+          <a:bodyPr/>
+          <a:p/>
+        </p:txBody>
       </p:sp>
       <p:sp>
         <p:nvSpPr>
@@ -7307,6 +7399,10 @@
             <a:noFill/>
           </a:ln>
         </p:spPr>
+        <p:txBody xmlns:a="http://schemas.openxmlformats.org/drawingml/2006/main">
+          <a:bodyPr/>
+          <a:p/>
+        </p:txBody>
       </p:sp>
       <p:sp>
         <p:nvSpPr>
@@ -7508,6 +7604,10 @@
             <a:noFill/>
           </a:ln>
         </p:spPr>
+        <p:txBody xmlns:a="http://schemas.openxmlformats.org/drawingml/2006/main">
+          <a:bodyPr/>
+          <a:p/>
+        </p:txBody>
       </p:sp>
       <p:sp>
         <p:nvSpPr>
@@ -7795,6 +7895,10 @@
             <a:noFill/>
           </a:ln>
         </p:spPr>
+        <p:txBody xmlns:a="http://schemas.openxmlformats.org/drawingml/2006/main">
+          <a:bodyPr/>
+          <a:p/>
+        </p:txBody>
       </p:sp>
       <p:sp>
         <p:nvSpPr>
@@ -7825,6 +7929,10 @@
             <a:noFill/>
           </a:ln>
         </p:spPr>
+        <p:txBody xmlns:a="http://schemas.openxmlformats.org/drawingml/2006/main">
+          <a:bodyPr/>
+          <a:p/>
+        </p:txBody>
       </p:sp>
       <p:sp>
         <p:nvSpPr>
@@ -7969,6 +8077,10 @@
             <a:noFill/>
           </a:ln>
         </p:spPr>
+        <p:txBody xmlns:a="http://schemas.openxmlformats.org/drawingml/2006/main">
+          <a:bodyPr/>
+          <a:p/>
+        </p:txBody>
       </p:sp>
       <p:sp>
         <p:nvSpPr>
@@ -8182,6 +8294,10 @@
             <a:noFill/>
           </a:ln>
         </p:spPr>
+        <p:txBody xmlns:a="http://schemas.openxmlformats.org/drawingml/2006/main">
+          <a:bodyPr/>
+          <a:p/>
+        </p:txBody>
       </p:sp>
       <p:sp>
         <p:nvSpPr>
@@ -8395,6 +8511,10 @@
             <a:noFill/>
           </a:ln>
         </p:spPr>
+        <p:txBody xmlns:a="http://schemas.openxmlformats.org/drawingml/2006/main">
+          <a:bodyPr/>
+          <a:p/>
+        </p:txBody>
       </p:sp>
       <p:sp>
         <p:nvSpPr>
@@ -8608,6 +8728,10 @@
             <a:noFill/>
           </a:ln>
         </p:spPr>
+        <p:txBody xmlns:a="http://schemas.openxmlformats.org/drawingml/2006/main">
+          <a:bodyPr/>
+          <a:p/>
+        </p:txBody>
       </p:sp>
       <p:sp>
         <p:nvSpPr>
@@ -9021,6 +9145,10 @@
             <a:noFill/>
           </a:ln>
         </p:spPr>
+        <p:txBody xmlns:a="http://schemas.openxmlformats.org/drawingml/2006/main">
+          <a:bodyPr/>
+          <a:p/>
+        </p:txBody>
       </p:sp>
       <p:sp>
         <p:nvSpPr>
@@ -9051,6 +9179,10 @@
             <a:noFill/>
           </a:ln>
         </p:spPr>
+        <p:txBody xmlns:a="http://schemas.openxmlformats.org/drawingml/2006/main">
+          <a:bodyPr/>
+          <a:p/>
+        </p:txBody>
       </p:sp>
       <p:sp>
         <p:nvSpPr>
@@ -9591,6 +9723,10 @@
             <a:noFill/>
           </a:ln>
         </p:spPr>
+        <p:txBody xmlns:a="http://schemas.openxmlformats.org/drawingml/2006/main">
+          <a:bodyPr/>
+          <a:p/>
+        </p:txBody>
       </p:sp>
       <p:sp>
         <p:nvSpPr>
@@ -9621,6 +9757,10 @@
             <a:noFill/>
           </a:ln>
         </p:spPr>
+        <p:txBody xmlns:a="http://schemas.openxmlformats.org/drawingml/2006/main">
+          <a:bodyPr/>
+          <a:p/>
+        </p:txBody>
       </p:sp>
       <p:sp>
         <p:nvSpPr>
@@ -10472,6 +10612,10 @@
             <a:noFill/>
           </a:ln>
         </p:spPr>
+        <p:txBody xmlns:a="http://schemas.openxmlformats.org/drawingml/2006/main">
+          <a:bodyPr/>
+          <a:p/>
+        </p:txBody>
       </p:sp>
       <p:sp>
         <p:nvSpPr>
@@ -10502,6 +10646,10 @@
             <a:noFill/>
           </a:ln>
         </p:spPr>
+        <p:txBody xmlns:a="http://schemas.openxmlformats.org/drawingml/2006/main">
+          <a:bodyPr/>
+          <a:p/>
+        </p:txBody>
       </p:sp>
       <p:sp>
         <p:nvSpPr>
@@ -11441,6 +11589,10 @@
             <a:noFill/>
           </a:ln>
         </p:spPr>
+        <p:txBody xmlns:a="http://schemas.openxmlformats.org/drawingml/2006/main">
+          <a:bodyPr/>
+          <a:p/>
+        </p:txBody>
       </p:sp>
       <p:sp>
         <p:nvSpPr>
@@ -11471,6 +11623,10 @@
             <a:noFill/>
           </a:ln>
         </p:spPr>
+        <p:txBody xmlns:a="http://schemas.openxmlformats.org/drawingml/2006/main">
+          <a:bodyPr/>
+          <a:p/>
+        </p:txBody>
       </p:sp>
       <p:sp>
         <p:nvSpPr>
@@ -11615,6 +11771,10 @@
             <a:noFill/>
           </a:ln>
         </p:spPr>
+        <p:txBody xmlns:a="http://schemas.openxmlformats.org/drawingml/2006/main">
+          <a:bodyPr/>
+          <a:p/>
+        </p:txBody>
       </p:sp>
       <p:sp>
         <p:nvSpPr>
@@ -11884,6 +12044,10 @@
             <a:noFill/>
           </a:ln>
         </p:spPr>
+        <p:txBody xmlns:a="http://schemas.openxmlformats.org/drawingml/2006/main">
+          <a:bodyPr/>
+          <a:p/>
+        </p:txBody>
       </p:sp>
       <p:sp>
         <p:nvSpPr>
@@ -12353,6 +12517,10 @@
             <a:noFill/>
           </a:ln>
         </p:spPr>
+        <p:txBody xmlns:a="http://schemas.openxmlformats.org/drawingml/2006/main">
+          <a:bodyPr/>
+          <a:p/>
+        </p:txBody>
       </p:sp>
       <p:sp>
         <p:nvSpPr>
@@ -12383,6 +12551,10 @@
             <a:noFill/>
           </a:ln>
         </p:spPr>
+        <p:txBody xmlns:a="http://schemas.openxmlformats.org/drawingml/2006/main">
+          <a:bodyPr/>
+          <a:p/>
+        </p:txBody>
       </p:sp>
       <p:sp>
         <p:nvSpPr>

</xml_diff>